<commit_message>
updates(2026-05-27): Code+Cowork architecture + de-jargon pass on Sara decks
</commit_message>
<xml_diff>
--- a/clients/sara/Sara-Proposal.pptx
+++ b/clients/sara/Sara-Proposal.pptx
@@ -3133,7 +3133,7 @@
                 </a:solidFill>
                 <a:latin typeface="Calibri"/>
               </a:rPr>
-              <a:t>CLAUDE COWORK SETUP · PROPOSTA · MAIO 2026</a:t>
+              <a:t>PRACTICE COMMAND · CODE + COWORK · PROPOSTA · MAIO 2026</a:t>
             </a:r>
           </a:p>
         </p:txBody>
@@ -3182,28 +3182,28 @@
         <p:spPr>
           <a:xfrm>
             <a:off x="914400" y="3529584"/>
-            <a:ext cx="10972800" cy="914400"/>
-          </a:xfrm>
-          <a:prstGeom prst="rect">
-            <a:avLst/>
-          </a:prstGeom>
-          <a:noFill/>
-        </p:spPr>
-        <p:txBody>
-          <a:bodyPr wrap="square" lIns="0" rIns="0" tIns="0" bIns="0" anchor="t">
-            <a:spAutoFit/>
-          </a:bodyPr>
-          <a:lstStyle/>
-          <a:p>
-            <a:pPr algn="l"/>
-            <a:r>
-              <a:rPr sz="1800" b="0" i="0">
+            <a:ext cx="10972800" cy="1097280"/>
+          </a:xfrm>
+          <a:prstGeom prst="rect">
+            <a:avLst/>
+          </a:prstGeom>
+          <a:noFill/>
+        </p:spPr>
+        <p:txBody>
+          <a:bodyPr wrap="square" lIns="0" rIns="0" tIns="0" bIns="0" anchor="t">
+            <a:spAutoFit/>
+          </a:bodyPr>
+          <a:lstStyle/>
+          <a:p>
+            <a:pPr algn="l"/>
+            <a:r>
+              <a:rPr sz="1700" b="0" i="0">
                 <a:solidFill>
                   <a:srgbClr val="4B5563"/>
                 </a:solidFill>
                 <a:latin typeface="Calibri"/>
               </a:rPr>
-              <a:t>Quatro prioridades, uma camada de inteligência sobre a automação que já tem em funcionamento. Não substitui — amplia.</a:t>
+              <a:t>Quatro prioridades. Dois runtimes Claude — Code sempre ligado para o tempo real, Cowork como cockpit da proprietária. Uma camada de inteligência sobre a automação que já tem em funcionamento.</a:t>
             </a:r>
           </a:p>
         </p:txBody>
@@ -5723,7 +5723,7 @@
                 </a:solidFill>
                 <a:latin typeface="Calibri"/>
               </a:rPr>
-              <a:t>ARQUITETURA · LOOP AUTO-MELHORÁVEL</a:t>
+              <a:t>ARQUITETURA · LOOP AUTO-MELHORÁVEL · CODE + COWORK</a:t>
             </a:r>
           </a:p>
         </p:txBody>
@@ -5793,7 +5793,7 @@
                 </a:solidFill>
                 <a:latin typeface="Calibri"/>
               </a:rPr>
-              <a:t>Não vai ficar com automações. Vai ficar com um sistema que se compõe com o uso — uma base de dados permanente, um loop de cinco passos, e os humanos só onde a realidade exige.</a:t>
+              <a:t>Dois runtimes Claude sobre a mesma base de dados central: Claude Code (motor sempre ligado para tempo-real) + Claude Cowork (cockpit da proprietária). Mesmas tabelas, mesmas ferramentas, mesma voz da clínica.</a:t>
             </a:r>
           </a:p>
         </p:txBody>
@@ -5806,8 +5806,398 @@
         </p:nvSpPr>
         <p:spPr>
           <a:xfrm>
-            <a:off x="914400" y="3657600"/>
-            <a:ext cx="3017520" cy="2926080"/>
+            <a:off x="914400" y="3520440"/>
+            <a:ext cx="8001000" cy="1371600"/>
+          </a:xfrm>
+          <a:prstGeom prst="roundRect">
+            <a:avLst>
+              <a:gd name="adj" fmla="val 3000"/>
+            </a:avLst>
+          </a:prstGeom>
+          <a:solidFill>
+            <a:srgbClr val="F7F1E8"/>
+          </a:solidFill>
+          <a:ln>
+            <a:noFill/>
+          </a:ln>
+          <a:effectLst/>
+        </p:spPr>
+        <p:style>
+          <a:lnRef idx="1">
+            <a:schemeClr val="accent1"/>
+          </a:lnRef>
+          <a:fillRef idx="3">
+            <a:schemeClr val="accent1"/>
+          </a:fillRef>
+          <a:effectRef idx="2">
+            <a:schemeClr val="accent1"/>
+          </a:effectRef>
+          <a:fontRef idx="minor">
+            <a:schemeClr val="lt1"/>
+          </a:fontRef>
+        </p:style>
+        <p:txBody>
+          <a:bodyPr rtlCol="0" anchor="ctr"/>
+          <a:lstStyle/>
+          <a:p>
+            <a:pPr algn="ctr"/>
+          </a:p>
+        </p:txBody>
+      </p:sp>
+      <p:sp>
+        <p:nvSpPr>
+          <p:cNvPr id="6" name="Rectangle 5"/>
+          <p:cNvSpPr/>
+          <p:nvPr/>
+        </p:nvSpPr>
+        <p:spPr>
+          <a:xfrm>
+            <a:off x="914400" y="3520440"/>
+            <a:ext cx="73152" cy="1371600"/>
+          </a:xfrm>
+          <a:prstGeom prst="rect">
+            <a:avLst/>
+          </a:prstGeom>
+          <a:solidFill>
+            <a:srgbClr val="FF8449"/>
+          </a:solidFill>
+          <a:ln>
+            <a:noFill/>
+          </a:ln>
+          <a:effectLst/>
+        </p:spPr>
+        <p:style>
+          <a:lnRef idx="1">
+            <a:schemeClr val="accent1"/>
+          </a:lnRef>
+          <a:fillRef idx="3">
+            <a:schemeClr val="accent1"/>
+          </a:fillRef>
+          <a:effectRef idx="2">
+            <a:schemeClr val="accent1"/>
+          </a:effectRef>
+          <a:fontRef idx="minor">
+            <a:schemeClr val="lt1"/>
+          </a:fontRef>
+        </p:style>
+        <p:txBody>
+          <a:bodyPr rtlCol="0" anchor="ctr"/>
+          <a:lstStyle/>
+          <a:p>
+            <a:pPr algn="ctr"/>
+          </a:p>
+        </p:txBody>
+      </p:sp>
+      <p:sp>
+        <p:nvSpPr>
+          <p:cNvPr id="7" name="TextBox 6"/>
+          <p:cNvSpPr txBox="1"/>
+          <p:nvPr/>
+        </p:nvSpPr>
+        <p:spPr>
+          <a:xfrm>
+            <a:off x="1188720" y="3685032"/>
+            <a:ext cx="7452360" cy="274320"/>
+          </a:xfrm>
+          <a:prstGeom prst="rect">
+            <a:avLst/>
+          </a:prstGeom>
+          <a:noFill/>
+        </p:spPr>
+        <p:txBody>
+          <a:bodyPr wrap="square" lIns="0" rIns="0" tIns="0" bIns="0" anchor="t">
+            <a:spAutoFit/>
+          </a:bodyPr>
+          <a:lstStyle/>
+          <a:p>
+            <a:pPr algn="l"/>
+            <a:r>
+              <a:rPr sz="825" b="0" i="0" spc="80">
+                <a:solidFill>
+                  <a:srgbClr val="FF8449"/>
+                </a:solidFill>
+                <a:latin typeface="Calibri"/>
+              </a:rPr>
+              <a:t>DAEMON · TEMPO REAL</a:t>
+            </a:r>
+          </a:p>
+        </p:txBody>
+      </p:sp>
+      <p:sp>
+        <p:nvSpPr>
+          <p:cNvPr id="8" name="TextBox 7"/>
+          <p:cNvSpPr txBox="1"/>
+          <p:nvPr/>
+        </p:nvSpPr>
+        <p:spPr>
+          <a:xfrm>
+            <a:off x="1188720" y="3913632"/>
+            <a:ext cx="7452360" cy="384048"/>
+          </a:xfrm>
+          <a:prstGeom prst="rect">
+            <a:avLst/>
+          </a:prstGeom>
+          <a:noFill/>
+        </p:spPr>
+        <p:txBody>
+          <a:bodyPr wrap="square" lIns="0" rIns="0" tIns="0" bIns="0" anchor="t">
+            <a:spAutoFit/>
+          </a:bodyPr>
+          <a:lstStyle/>
+          <a:p>
+            <a:pPr algn="l"/>
+            <a:r>
+              <a:rPr sz="2000" b="0" i="0">
+                <a:solidFill>
+                  <a:srgbClr val="000000"/>
+                </a:solidFill>
+                <a:latin typeface="Georgia"/>
+              </a:rPr>
+              <a:t>Claude Code</a:t>
+            </a:r>
+          </a:p>
+        </p:txBody>
+      </p:sp>
+      <p:sp>
+        <p:nvSpPr>
+          <p:cNvPr id="9" name="TextBox 8"/>
+          <p:cNvSpPr txBox="1"/>
+          <p:nvPr/>
+        </p:nvSpPr>
+        <p:spPr>
+          <a:xfrm>
+            <a:off x="1188720" y="4343400"/>
+            <a:ext cx="7452360" cy="457200"/>
+          </a:xfrm>
+          <a:prstGeom prst="rect">
+            <a:avLst/>
+          </a:prstGeom>
+          <a:noFill/>
+        </p:spPr>
+        <p:txBody>
+          <a:bodyPr wrap="square" lIns="0" rIns="0" tIns="0" bIns="0" anchor="t">
+            <a:spAutoFit/>
+          </a:bodyPr>
+          <a:lstStyle/>
+          <a:p>
+            <a:pPr algn="l"/>
+            <a:r>
+              <a:rPr sz="1050" b="0" i="0">
+                <a:solidFill>
+                  <a:srgbClr val="4B5563"/>
+                </a:solidFill>
+                <a:latin typeface="Calibri"/>
+              </a:rPr>
+              <a:t>Sempre ligado no VPS da clínica. Webhooks + cron. Sub-minuto. Owns mensagens automáticas, triagem inbound, tempos críticos (T-24h, T+6h, reativação).</a:t>
+            </a:r>
+          </a:p>
+        </p:txBody>
+      </p:sp>
+      <p:sp>
+        <p:nvSpPr>
+          <p:cNvPr id="10" name="Rounded Rectangle 9"/>
+          <p:cNvSpPr/>
+          <p:nvPr/>
+        </p:nvSpPr>
+        <p:spPr>
+          <a:xfrm>
+            <a:off x="9372600" y="3520440"/>
+            <a:ext cx="8001000" cy="1371600"/>
+          </a:xfrm>
+          <a:prstGeom prst="roundRect">
+            <a:avLst>
+              <a:gd name="adj" fmla="val 3000"/>
+            </a:avLst>
+          </a:prstGeom>
+          <a:solidFill>
+            <a:srgbClr val="F7F1E8"/>
+          </a:solidFill>
+          <a:ln>
+            <a:noFill/>
+          </a:ln>
+          <a:effectLst/>
+        </p:spPr>
+        <p:style>
+          <a:lnRef idx="1">
+            <a:schemeClr val="accent1"/>
+          </a:lnRef>
+          <a:fillRef idx="3">
+            <a:schemeClr val="accent1"/>
+          </a:fillRef>
+          <a:effectRef idx="2">
+            <a:schemeClr val="accent1"/>
+          </a:effectRef>
+          <a:fontRef idx="minor">
+            <a:schemeClr val="lt1"/>
+          </a:fontRef>
+        </p:style>
+        <p:txBody>
+          <a:bodyPr rtlCol="0" anchor="ctr"/>
+          <a:lstStyle/>
+          <a:p>
+            <a:pPr algn="ctr"/>
+          </a:p>
+        </p:txBody>
+      </p:sp>
+      <p:sp>
+        <p:nvSpPr>
+          <p:cNvPr id="11" name="Rectangle 10"/>
+          <p:cNvSpPr/>
+          <p:nvPr/>
+        </p:nvSpPr>
+        <p:spPr>
+          <a:xfrm>
+            <a:off x="9372600" y="3520440"/>
+            <a:ext cx="73152" cy="1371600"/>
+          </a:xfrm>
+          <a:prstGeom prst="rect">
+            <a:avLst/>
+          </a:prstGeom>
+          <a:solidFill>
+            <a:srgbClr val="FF8449"/>
+          </a:solidFill>
+          <a:ln>
+            <a:noFill/>
+          </a:ln>
+          <a:effectLst/>
+        </p:spPr>
+        <p:style>
+          <a:lnRef idx="1">
+            <a:schemeClr val="accent1"/>
+          </a:lnRef>
+          <a:fillRef idx="3">
+            <a:schemeClr val="accent1"/>
+          </a:fillRef>
+          <a:effectRef idx="2">
+            <a:schemeClr val="accent1"/>
+          </a:effectRef>
+          <a:fontRef idx="minor">
+            <a:schemeClr val="lt1"/>
+          </a:fontRef>
+        </p:style>
+        <p:txBody>
+          <a:bodyPr rtlCol="0" anchor="ctr"/>
+          <a:lstStyle/>
+          <a:p>
+            <a:pPr algn="ctr"/>
+          </a:p>
+        </p:txBody>
+      </p:sp>
+      <p:sp>
+        <p:nvSpPr>
+          <p:cNvPr id="12" name="TextBox 11"/>
+          <p:cNvSpPr txBox="1"/>
+          <p:nvPr/>
+        </p:nvSpPr>
+        <p:spPr>
+          <a:xfrm>
+            <a:off x="9646920" y="3685032"/>
+            <a:ext cx="7452360" cy="274320"/>
+          </a:xfrm>
+          <a:prstGeom prst="rect">
+            <a:avLst/>
+          </a:prstGeom>
+          <a:noFill/>
+        </p:spPr>
+        <p:txBody>
+          <a:bodyPr wrap="square" lIns="0" rIns="0" tIns="0" bIns="0" anchor="t">
+            <a:spAutoFit/>
+          </a:bodyPr>
+          <a:lstStyle/>
+          <a:p>
+            <a:pPr algn="l"/>
+            <a:r>
+              <a:rPr sz="825" b="0" i="0" spc="80">
+                <a:solidFill>
+                  <a:srgbClr val="FF8449"/>
+                </a:solidFill>
+                <a:latin typeface="Calibri"/>
+              </a:rPr>
+              <a:t>COCKPIT · PROPRIETÁRIA</a:t>
+            </a:r>
+          </a:p>
+        </p:txBody>
+      </p:sp>
+      <p:sp>
+        <p:nvSpPr>
+          <p:cNvPr id="13" name="TextBox 12"/>
+          <p:cNvSpPr txBox="1"/>
+          <p:nvPr/>
+        </p:nvSpPr>
+        <p:spPr>
+          <a:xfrm>
+            <a:off x="9646920" y="3913632"/>
+            <a:ext cx="7452360" cy="384048"/>
+          </a:xfrm>
+          <a:prstGeom prst="rect">
+            <a:avLst/>
+          </a:prstGeom>
+          <a:noFill/>
+        </p:spPr>
+        <p:txBody>
+          <a:bodyPr wrap="square" lIns="0" rIns="0" tIns="0" bIns="0" anchor="t">
+            <a:spAutoFit/>
+          </a:bodyPr>
+          <a:lstStyle/>
+          <a:p>
+            <a:pPr algn="l"/>
+            <a:r>
+              <a:rPr sz="2000" b="0" i="0">
+                <a:solidFill>
+                  <a:srgbClr val="000000"/>
+                </a:solidFill>
+                <a:latin typeface="Georgia"/>
+              </a:rPr>
+              <a:t>Claude Cowork</a:t>
+            </a:r>
+          </a:p>
+        </p:txBody>
+      </p:sp>
+      <p:sp>
+        <p:nvSpPr>
+          <p:cNvPr id="14" name="TextBox 13"/>
+          <p:cNvSpPr txBox="1"/>
+          <p:nvPr/>
+        </p:nvSpPr>
+        <p:spPr>
+          <a:xfrm>
+            <a:off x="9646920" y="4343400"/>
+            <a:ext cx="7452360" cy="457200"/>
+          </a:xfrm>
+          <a:prstGeom prst="rect">
+            <a:avLst/>
+          </a:prstGeom>
+          <a:noFill/>
+        </p:spPr>
+        <p:txBody>
+          <a:bodyPr wrap="square" lIns="0" rIns="0" tIns="0" bIns="0" anchor="t">
+            <a:spAutoFit/>
+          </a:bodyPr>
+          <a:lstStyle/>
+          <a:p>
+            <a:pPr algn="l"/>
+            <a:r>
+              <a:rPr sz="1050" b="0" i="0">
+                <a:solidFill>
+                  <a:srgbClr val="4B5563"/>
+                </a:solidFill>
+                <a:latin typeface="Calibri"/>
+              </a:rPr>
+              <a:t>Desktop da Sara. Briefing diário, fila de aprovação, learning loop semanal, conversas ad-hoc, revisões mensais.</a:t>
+            </a:r>
+          </a:p>
+        </p:txBody>
+      </p:sp>
+      <p:sp>
+        <p:nvSpPr>
+          <p:cNvPr id="15" name="Rounded Rectangle 14"/>
+          <p:cNvSpPr/>
+          <p:nvPr/>
+        </p:nvSpPr>
+        <p:spPr>
+          <a:xfrm>
+            <a:off x="914400" y="5212080"/>
+            <a:ext cx="3017520" cy="2651760"/>
           </a:xfrm>
           <a:prstGeom prst="roundRect">
             <a:avLst>
@@ -5846,13 +6236,13 @@
       </p:sp>
       <p:sp>
         <p:nvSpPr>
-          <p:cNvPr id="6" name="TextBox 5"/>
-          <p:cNvSpPr txBox="1"/>
-          <p:nvPr/>
-        </p:nvSpPr>
-        <p:spPr>
-          <a:xfrm>
-            <a:off x="1188720" y="3886200"/>
+          <p:cNvPr id="16" name="TextBox 15"/>
+          <p:cNvSpPr txBox="1"/>
+          <p:nvPr/>
+        </p:nvSpPr>
+        <p:spPr>
+          <a:xfrm>
+            <a:off x="1188720" y="5440680"/>
             <a:ext cx="1371600" cy="411480"/>
           </a:xfrm>
           <a:prstGeom prst="rect">
@@ -5881,13 +6271,13 @@
       </p:sp>
       <p:sp>
         <p:nvSpPr>
-          <p:cNvPr id="7" name="TextBox 6"/>
-          <p:cNvSpPr txBox="1"/>
-          <p:nvPr/>
-        </p:nvSpPr>
-        <p:spPr>
-          <a:xfrm>
-            <a:off x="1188720" y="4434840"/>
+          <p:cNvPr id="17" name="TextBox 16"/>
+          <p:cNvSpPr txBox="1"/>
+          <p:nvPr/>
+        </p:nvSpPr>
+        <p:spPr>
+          <a:xfrm>
+            <a:off x="1188720" y="5989320"/>
             <a:ext cx="2468879" cy="274320"/>
           </a:xfrm>
           <a:prstGeom prst="rect">
@@ -5916,13 +6306,13 @@
       </p:sp>
       <p:sp>
         <p:nvSpPr>
-          <p:cNvPr id="8" name="TextBox 7"/>
-          <p:cNvSpPr txBox="1"/>
-          <p:nvPr/>
-        </p:nvSpPr>
-        <p:spPr>
-          <a:xfrm>
-            <a:off x="1188720" y="4709160"/>
+          <p:cNvPr id="18" name="TextBox 17"/>
+          <p:cNvSpPr txBox="1"/>
+          <p:nvPr/>
+        </p:nvSpPr>
+        <p:spPr>
+          <a:xfrm>
+            <a:off x="1188720" y="6263640"/>
             <a:ext cx="2468879" cy="548640"/>
           </a:xfrm>
           <a:prstGeom prst="rect">
@@ -5951,14 +6341,14 @@
       </p:sp>
       <p:sp>
         <p:nvSpPr>
-          <p:cNvPr id="9" name="TextBox 8"/>
-          <p:cNvSpPr txBox="1"/>
-          <p:nvPr/>
-        </p:nvSpPr>
-        <p:spPr>
-          <a:xfrm>
-            <a:off x="1188720" y="5349240"/>
-            <a:ext cx="2468879" cy="1097280"/>
+          <p:cNvPr id="19" name="TextBox 18"/>
+          <p:cNvSpPr txBox="1"/>
+          <p:nvPr/>
+        </p:nvSpPr>
+        <p:spPr>
+          <a:xfrm>
+            <a:off x="1188720" y="6903720"/>
+            <a:ext cx="2468879" cy="822959"/>
           </a:xfrm>
           <a:prstGeom prst="rect">
             <a:avLst/>
@@ -5979,20 +6369,20 @@
                 </a:solidFill>
                 <a:latin typeface="Calibri"/>
               </a:rPr>
-              <a:t>Eventos da agenda, mensagens recebidas, notas das consultas, respostas dos pacientes.</a:t>
-            </a:r>
-          </a:p>
-        </p:txBody>
-      </p:sp>
-      <p:sp>
-        <p:nvSpPr>
-          <p:cNvPr id="10" name="Right Arrow 9"/>
+              <a:t>Code escuta webhooks (WhatsApp, agenda, sessão concluída). Cowork puxa contexto on-demand.</a:t>
+            </a:r>
+          </a:p>
+        </p:txBody>
+      </p:sp>
+      <p:sp>
+        <p:nvSpPr>
+          <p:cNvPr id="20" name="Right Arrow 19"/>
           <p:cNvSpPr/>
           <p:nvPr/>
         </p:nvSpPr>
         <p:spPr>
           <a:xfrm>
-            <a:off x="3986783" y="5010912"/>
+            <a:off x="3986783" y="6428232"/>
             <a:ext cx="246888" cy="228600"/>
           </a:xfrm>
           <a:prstGeom prst="rightArrow">
@@ -6030,14 +6420,14 @@
       </p:sp>
       <p:sp>
         <p:nvSpPr>
-          <p:cNvPr id="11" name="Rounded Rectangle 10"/>
+          <p:cNvPr id="21" name="Rounded Rectangle 20"/>
           <p:cNvSpPr/>
           <p:nvPr/>
         </p:nvSpPr>
         <p:spPr>
           <a:xfrm>
-            <a:off x="4297679" y="3657600"/>
-            <a:ext cx="3017520" cy="2926080"/>
+            <a:off x="4297679" y="5212080"/>
+            <a:ext cx="3017520" cy="2651760"/>
           </a:xfrm>
           <a:prstGeom prst="roundRect">
             <a:avLst>
@@ -6076,13 +6466,13 @@
       </p:sp>
       <p:sp>
         <p:nvSpPr>
-          <p:cNvPr id="12" name="TextBox 11"/>
-          <p:cNvSpPr txBox="1"/>
-          <p:nvPr/>
-        </p:nvSpPr>
-        <p:spPr>
-          <a:xfrm>
-            <a:off x="4571999" y="3886200"/>
+          <p:cNvPr id="22" name="TextBox 21"/>
+          <p:cNvSpPr txBox="1"/>
+          <p:nvPr/>
+        </p:nvSpPr>
+        <p:spPr>
+          <a:xfrm>
+            <a:off x="4571999" y="5440680"/>
             <a:ext cx="1371600" cy="411480"/>
           </a:xfrm>
           <a:prstGeom prst="rect">
@@ -6111,13 +6501,13 @@
       </p:sp>
       <p:sp>
         <p:nvSpPr>
-          <p:cNvPr id="13" name="TextBox 12"/>
-          <p:cNvSpPr txBox="1"/>
-          <p:nvPr/>
-        </p:nvSpPr>
-        <p:spPr>
-          <a:xfrm>
-            <a:off x="4571999" y="4434840"/>
+          <p:cNvPr id="23" name="TextBox 22"/>
+          <p:cNvSpPr txBox="1"/>
+          <p:nvPr/>
+        </p:nvSpPr>
+        <p:spPr>
+          <a:xfrm>
+            <a:off x="4571999" y="5989320"/>
             <a:ext cx="2468879" cy="274320"/>
           </a:xfrm>
           <a:prstGeom prst="rect">
@@ -6146,13 +6536,13 @@
       </p:sp>
       <p:sp>
         <p:nvSpPr>
-          <p:cNvPr id="14" name="TextBox 13"/>
-          <p:cNvSpPr txBox="1"/>
-          <p:nvPr/>
-        </p:nvSpPr>
-        <p:spPr>
-          <a:xfrm>
-            <a:off x="4571999" y="4709160"/>
+          <p:cNvPr id="24" name="TextBox 23"/>
+          <p:cNvSpPr txBox="1"/>
+          <p:nvPr/>
+        </p:nvSpPr>
+        <p:spPr>
+          <a:xfrm>
+            <a:off x="4571999" y="6263640"/>
             <a:ext cx="2468879" cy="548640"/>
           </a:xfrm>
           <a:prstGeom prst="rect">
@@ -6181,14 +6571,14 @@
       </p:sp>
       <p:sp>
         <p:nvSpPr>
-          <p:cNvPr id="15" name="TextBox 14"/>
-          <p:cNvSpPr txBox="1"/>
-          <p:nvPr/>
-        </p:nvSpPr>
-        <p:spPr>
-          <a:xfrm>
-            <a:off x="4571999" y="5349240"/>
-            <a:ext cx="2468879" cy="1097280"/>
+          <p:cNvPr id="25" name="TextBox 24"/>
+          <p:cNvSpPr txBox="1"/>
+          <p:nvPr/>
+        </p:nvSpPr>
+        <p:spPr>
+          <a:xfrm>
+            <a:off x="4571999" y="6903720"/>
+            <a:ext cx="2468879" cy="822959"/>
           </a:xfrm>
           <a:prstGeom prst="rect">
             <a:avLst/>
@@ -6209,20 +6599,20 @@
                 </a:solidFill>
                 <a:latin typeface="Calibri"/>
               </a:rPr>
-              <a:t>Claude lê o contexto e decide: responder, escalar, escalar à Sara, ou registar.</a:t>
-            </a:r>
-          </a:p>
-        </p:txBody>
-      </p:sp>
-      <p:sp>
-        <p:nvSpPr>
-          <p:cNvPr id="16" name="Right Arrow 15"/>
+              <a:t>Code decide em tempo real por evento. Cowork decide o que mostrar à Sara.</a:t>
+            </a:r>
+          </a:p>
+        </p:txBody>
+      </p:sp>
+      <p:sp>
+        <p:nvSpPr>
+          <p:cNvPr id="26" name="Right Arrow 25"/>
           <p:cNvSpPr/>
           <p:nvPr/>
         </p:nvSpPr>
         <p:spPr>
           <a:xfrm>
-            <a:off x="7370063" y="5010912"/>
+            <a:off x="7370063" y="6428232"/>
             <a:ext cx="246888" cy="228600"/>
           </a:xfrm>
           <a:prstGeom prst="rightArrow">
@@ -6260,14 +6650,14 @@
       </p:sp>
       <p:sp>
         <p:nvSpPr>
-          <p:cNvPr id="17" name="Rounded Rectangle 16"/>
+          <p:cNvPr id="27" name="Rounded Rectangle 26"/>
           <p:cNvSpPr/>
           <p:nvPr/>
         </p:nvSpPr>
         <p:spPr>
           <a:xfrm>
-            <a:off x="7680959" y="3657600"/>
-            <a:ext cx="3017520" cy="2926080"/>
+            <a:off x="7680959" y="5212080"/>
+            <a:ext cx="3017520" cy="2651760"/>
           </a:xfrm>
           <a:prstGeom prst="roundRect">
             <a:avLst>
@@ -6306,13 +6696,13 @@
       </p:sp>
       <p:sp>
         <p:nvSpPr>
-          <p:cNvPr id="18" name="TextBox 17"/>
-          <p:cNvSpPr txBox="1"/>
-          <p:nvPr/>
-        </p:nvSpPr>
-        <p:spPr>
-          <a:xfrm>
-            <a:off x="7955279" y="3886200"/>
+          <p:cNvPr id="28" name="TextBox 27"/>
+          <p:cNvSpPr txBox="1"/>
+          <p:nvPr/>
+        </p:nvSpPr>
+        <p:spPr>
+          <a:xfrm>
+            <a:off x="7955279" y="5440680"/>
             <a:ext cx="1371600" cy="411480"/>
           </a:xfrm>
           <a:prstGeom prst="rect">
@@ -6341,13 +6731,13 @@
       </p:sp>
       <p:sp>
         <p:nvSpPr>
-          <p:cNvPr id="19" name="TextBox 18"/>
-          <p:cNvSpPr txBox="1"/>
-          <p:nvPr/>
-        </p:nvSpPr>
-        <p:spPr>
-          <a:xfrm>
-            <a:off x="7955279" y="4434840"/>
+          <p:cNvPr id="29" name="TextBox 28"/>
+          <p:cNvSpPr txBox="1"/>
+          <p:nvPr/>
+        </p:nvSpPr>
+        <p:spPr>
+          <a:xfrm>
+            <a:off x="7955279" y="5989320"/>
             <a:ext cx="2468879" cy="274320"/>
           </a:xfrm>
           <a:prstGeom prst="rect">
@@ -6376,13 +6766,13 @@
       </p:sp>
       <p:sp>
         <p:nvSpPr>
-          <p:cNvPr id="20" name="TextBox 19"/>
-          <p:cNvSpPr txBox="1"/>
-          <p:nvPr/>
-        </p:nvSpPr>
-        <p:spPr>
-          <a:xfrm>
-            <a:off x="7955279" y="4709160"/>
+          <p:cNvPr id="30" name="TextBox 29"/>
+          <p:cNvSpPr txBox="1"/>
+          <p:nvPr/>
+        </p:nvSpPr>
+        <p:spPr>
+          <a:xfrm>
+            <a:off x="7955279" y="6263640"/>
             <a:ext cx="2468879" cy="548640"/>
           </a:xfrm>
           <a:prstGeom prst="rect">
@@ -6411,14 +6801,14 @@
       </p:sp>
       <p:sp>
         <p:nvSpPr>
-          <p:cNvPr id="21" name="TextBox 20"/>
-          <p:cNvSpPr txBox="1"/>
-          <p:nvPr/>
-        </p:nvSpPr>
-        <p:spPr>
-          <a:xfrm>
-            <a:off x="7955279" y="5349240"/>
-            <a:ext cx="2468879" cy="1097280"/>
+          <p:cNvPr id="31" name="TextBox 30"/>
+          <p:cNvSpPr txBox="1"/>
+          <p:nvPr/>
+        </p:nvSpPr>
+        <p:spPr>
+          <a:xfrm>
+            <a:off x="7955279" y="6903720"/>
+            <a:ext cx="2468879" cy="822959"/>
           </a:xfrm>
           <a:prstGeom prst="rect">
             <a:avLst/>
@@ -6439,20 +6829,20 @@
                 </a:solidFill>
                 <a:latin typeface="Calibri"/>
               </a:rPr>
-              <a:t>MCPs executam: agenda, WhatsApp, email, CRM, inferência local para dados clínicos.</a:t>
-            </a:r>
-          </a:p>
-        </p:txBody>
-      </p:sp>
-      <p:sp>
-        <p:nvSpPr>
-          <p:cNvPr id="22" name="Right Arrow 21"/>
+              <a:t>Os mesmos MCPs (agenda, WhatsApp, email, Airtable, Ollama) usados por ambos os runtimes.</a:t>
+            </a:r>
+          </a:p>
+        </p:txBody>
+      </p:sp>
+      <p:sp>
+        <p:nvSpPr>
+          <p:cNvPr id="32" name="Right Arrow 31"/>
           <p:cNvSpPr/>
           <p:nvPr/>
         </p:nvSpPr>
         <p:spPr>
           <a:xfrm>
-            <a:off x="10753344" y="5010912"/>
+            <a:off x="10753344" y="6428232"/>
             <a:ext cx="246888" cy="228600"/>
           </a:xfrm>
           <a:prstGeom prst="rightArrow">
@@ -6490,14 +6880,14 @@
       </p:sp>
       <p:sp>
         <p:nvSpPr>
-          <p:cNvPr id="23" name="Rounded Rectangle 22"/>
+          <p:cNvPr id="33" name="Rounded Rectangle 32"/>
           <p:cNvSpPr/>
           <p:nvPr/>
         </p:nvSpPr>
         <p:spPr>
           <a:xfrm>
-            <a:off x="11064240" y="3657600"/>
-            <a:ext cx="3017520" cy="2926080"/>
+            <a:off x="11064240" y="5212080"/>
+            <a:ext cx="3017520" cy="2651760"/>
           </a:xfrm>
           <a:prstGeom prst="roundRect">
             <a:avLst>
@@ -6536,13 +6926,13 @@
       </p:sp>
       <p:sp>
         <p:nvSpPr>
-          <p:cNvPr id="24" name="TextBox 23"/>
-          <p:cNvSpPr txBox="1"/>
-          <p:nvPr/>
-        </p:nvSpPr>
-        <p:spPr>
-          <a:xfrm>
-            <a:off x="11338560" y="3886200"/>
+          <p:cNvPr id="34" name="TextBox 33"/>
+          <p:cNvSpPr txBox="1"/>
+          <p:nvPr/>
+        </p:nvSpPr>
+        <p:spPr>
+          <a:xfrm>
+            <a:off x="11338560" y="5440680"/>
             <a:ext cx="1371600" cy="411480"/>
           </a:xfrm>
           <a:prstGeom prst="rect">
@@ -6571,13 +6961,13 @@
       </p:sp>
       <p:sp>
         <p:nvSpPr>
-          <p:cNvPr id="25" name="TextBox 24"/>
-          <p:cNvSpPr txBox="1"/>
-          <p:nvPr/>
-        </p:nvSpPr>
-        <p:spPr>
-          <a:xfrm>
-            <a:off x="11338560" y="4434840"/>
+          <p:cNvPr id="35" name="TextBox 34"/>
+          <p:cNvSpPr txBox="1"/>
+          <p:nvPr/>
+        </p:nvSpPr>
+        <p:spPr>
+          <a:xfrm>
+            <a:off x="11338560" y="5989320"/>
             <a:ext cx="2468879" cy="274320"/>
           </a:xfrm>
           <a:prstGeom prst="rect">
@@ -6606,13 +6996,13 @@
       </p:sp>
       <p:sp>
         <p:nvSpPr>
-          <p:cNvPr id="26" name="TextBox 25"/>
-          <p:cNvSpPr txBox="1"/>
-          <p:nvPr/>
-        </p:nvSpPr>
-        <p:spPr>
-          <a:xfrm>
-            <a:off x="11338560" y="4709160"/>
+          <p:cNvPr id="36" name="TextBox 35"/>
+          <p:cNvSpPr txBox="1"/>
+          <p:nvPr/>
+        </p:nvSpPr>
+        <p:spPr>
+          <a:xfrm>
+            <a:off x="11338560" y="6263640"/>
             <a:ext cx="2468879" cy="548640"/>
           </a:xfrm>
           <a:prstGeom prst="rect">
@@ -6641,14 +7031,14 @@
       </p:sp>
       <p:sp>
         <p:nvSpPr>
-          <p:cNvPr id="27" name="TextBox 26"/>
-          <p:cNvSpPr txBox="1"/>
-          <p:nvPr/>
-        </p:nvSpPr>
-        <p:spPr>
-          <a:xfrm>
-            <a:off x="11338560" y="5349240"/>
-            <a:ext cx="2468879" cy="1097280"/>
+          <p:cNvPr id="37" name="TextBox 36"/>
+          <p:cNvSpPr txBox="1"/>
+          <p:nvPr/>
+        </p:nvSpPr>
+        <p:spPr>
+          <a:xfrm>
+            <a:off x="11338560" y="6903720"/>
+            <a:ext cx="2468879" cy="822959"/>
           </a:xfrm>
           <a:prstGeom prst="rect">
             <a:avLst/>
@@ -6669,20 +7059,20 @@
                 </a:solidFill>
                 <a:latin typeface="Calibri"/>
               </a:rPr>
-              <a:t>Mensagens sensíveis aprovadas pela Sara. Verificação de voz da clínica e sanidade.</a:t>
-            </a:r>
-          </a:p>
-        </p:txBody>
-      </p:sp>
-      <p:sp>
-        <p:nvSpPr>
-          <p:cNvPr id="28" name="Right Arrow 27"/>
+              <a:t>Code escreve «em espera»; Cowork mostra à Sara; Sara aprova → Code envia.</a:t>
+            </a:r>
+          </a:p>
+        </p:txBody>
+      </p:sp>
+      <p:sp>
+        <p:nvSpPr>
+          <p:cNvPr id="38" name="Right Arrow 37"/>
           <p:cNvSpPr/>
           <p:nvPr/>
         </p:nvSpPr>
         <p:spPr>
           <a:xfrm>
-            <a:off x="14136624" y="5010912"/>
+            <a:off x="14136624" y="6428232"/>
             <a:ext cx="246888" cy="228600"/>
           </a:xfrm>
           <a:prstGeom prst="rightArrow">
@@ -6720,14 +7110,14 @@
       </p:sp>
       <p:sp>
         <p:nvSpPr>
-          <p:cNvPr id="29" name="Rounded Rectangle 28"/>
+          <p:cNvPr id="39" name="Rounded Rectangle 38"/>
           <p:cNvSpPr/>
           <p:nvPr/>
         </p:nvSpPr>
         <p:spPr>
           <a:xfrm>
-            <a:off x="14447519" y="3657600"/>
-            <a:ext cx="3017520" cy="2926080"/>
+            <a:off x="14447519" y="5212080"/>
+            <a:ext cx="3017520" cy="2651760"/>
           </a:xfrm>
           <a:prstGeom prst="roundRect">
             <a:avLst>
@@ -6766,13 +7156,13 @@
       </p:sp>
       <p:sp>
         <p:nvSpPr>
-          <p:cNvPr id="30" name="TextBox 29"/>
-          <p:cNvSpPr txBox="1"/>
-          <p:nvPr/>
-        </p:nvSpPr>
-        <p:spPr>
-          <a:xfrm>
-            <a:off x="14721839" y="3886200"/>
+          <p:cNvPr id="40" name="TextBox 39"/>
+          <p:cNvSpPr txBox="1"/>
+          <p:nvPr/>
+        </p:nvSpPr>
+        <p:spPr>
+          <a:xfrm>
+            <a:off x="14721839" y="5440680"/>
             <a:ext cx="1371600" cy="411480"/>
           </a:xfrm>
           <a:prstGeom prst="rect">
@@ -6801,13 +7191,13 @@
       </p:sp>
       <p:sp>
         <p:nvSpPr>
-          <p:cNvPr id="31" name="TextBox 30"/>
-          <p:cNvSpPr txBox="1"/>
-          <p:nvPr/>
-        </p:nvSpPr>
-        <p:spPr>
-          <a:xfrm>
-            <a:off x="14721839" y="4434840"/>
+          <p:cNvPr id="41" name="TextBox 40"/>
+          <p:cNvSpPr txBox="1"/>
+          <p:nvPr/>
+        </p:nvSpPr>
+        <p:spPr>
+          <a:xfrm>
+            <a:off x="14721839" y="5989320"/>
             <a:ext cx="2468879" cy="274320"/>
           </a:xfrm>
           <a:prstGeom prst="rect">
@@ -6836,13 +7226,13 @@
       </p:sp>
       <p:sp>
         <p:nvSpPr>
-          <p:cNvPr id="32" name="TextBox 31"/>
-          <p:cNvSpPr txBox="1"/>
-          <p:nvPr/>
-        </p:nvSpPr>
-        <p:spPr>
-          <a:xfrm>
-            <a:off x="14721839" y="4709160"/>
+          <p:cNvPr id="42" name="TextBox 41"/>
+          <p:cNvSpPr txBox="1"/>
+          <p:nvPr/>
+        </p:nvSpPr>
+        <p:spPr>
+          <a:xfrm>
+            <a:off x="14721839" y="6263640"/>
             <a:ext cx="2468879" cy="548640"/>
           </a:xfrm>
           <a:prstGeom prst="rect">
@@ -6871,14 +7261,14 @@
       </p:sp>
       <p:sp>
         <p:nvSpPr>
-          <p:cNvPr id="33" name="TextBox 32"/>
-          <p:cNvSpPr txBox="1"/>
-          <p:nvPr/>
-        </p:nvSpPr>
-        <p:spPr>
-          <a:xfrm>
-            <a:off x="14721839" y="5349240"/>
-            <a:ext cx="2468879" cy="1097280"/>
+          <p:cNvPr id="43" name="TextBox 42"/>
+          <p:cNvSpPr txBox="1"/>
+          <p:nvPr/>
+        </p:nvSpPr>
+        <p:spPr>
+          <a:xfrm>
+            <a:off x="14721839" y="6903720"/>
+            <a:ext cx="2468879" cy="822959"/>
           </a:xfrm>
           <a:prstGeom prst="rect">
             <a:avLst/>
@@ -6899,20 +7289,20 @@
                 </a:solidFill>
                 <a:latin typeface="Calibri"/>
               </a:rPr>
-              <a:t>Revisão semanal automática gera patches para os passos anteriores.</a:t>
-            </a:r>
-          </a:p>
-        </p:txBody>
-      </p:sp>
-      <p:sp>
-        <p:nvSpPr>
-          <p:cNvPr id="34" name="TextBox 33"/>
-          <p:cNvSpPr txBox="1"/>
-          <p:nvPr/>
-        </p:nvSpPr>
-        <p:spPr>
-          <a:xfrm>
-            <a:off x="914400" y="6812280"/>
+              <a:t>Cowork revê a semana, gera patches; ambos os runtimes apanham na próxima invocação.</a:t>
+            </a:r>
+          </a:p>
+        </p:txBody>
+      </p:sp>
+      <p:sp>
+        <p:nvSpPr>
+          <p:cNvPr id="44" name="TextBox 43"/>
+          <p:cNvSpPr txBox="1"/>
+          <p:nvPr/>
+        </p:nvSpPr>
+        <p:spPr>
+          <a:xfrm>
+            <a:off x="914400" y="8046720"/>
             <a:ext cx="16459200" cy="457200"/>
           </a:xfrm>
           <a:prstGeom prst="rect">
@@ -6928,27 +7318,27 @@
           <a:p>
             <a:pPr algn="l"/>
             <a:r>
-              <a:rPr sz="1200" b="0" i="1">
+              <a:rPr sz="1150" b="0" i="1">
                 <a:solidFill>
                   <a:srgbClr val="4B5563"/>
                 </a:solidFill>
                 <a:latin typeface="Georgia"/>
               </a:rPr>
-              <a:t>↻  Cada semana, o passo 5 atualiza o passo 2. O sistema melhora porque é usado, não porque alguém escreve código.</a:t>
-            </a:r>
-          </a:p>
-        </p:txBody>
-      </p:sp>
-      <p:sp>
-        <p:nvSpPr>
-          <p:cNvPr id="35" name="Rounded Rectangle 34"/>
+              <a:t>↻  Cada semana, o passo 5 atualiza o passo 2 — Code e Cowork apanham as melhorias da mesma source. O sistema melhora porque é usado.</a:t>
+            </a:r>
+          </a:p>
+        </p:txBody>
+      </p:sp>
+      <p:sp>
+        <p:nvSpPr>
+          <p:cNvPr id="45" name="Rounded Rectangle 44"/>
           <p:cNvSpPr/>
           <p:nvPr/>
         </p:nvSpPr>
         <p:spPr>
           <a:xfrm>
-            <a:off x="914400" y="7498079"/>
-            <a:ext cx="5242560" cy="1828800"/>
+            <a:off x="914400" y="8641080"/>
+            <a:ext cx="5242560" cy="1005840"/>
           </a:xfrm>
           <a:prstGeom prst="roundRect">
             <a:avLst>
@@ -6987,119 +7377,119 @@
       </p:sp>
       <p:sp>
         <p:nvSpPr>
-          <p:cNvPr id="36" name="TextBox 35"/>
-          <p:cNvSpPr txBox="1"/>
-          <p:nvPr/>
-        </p:nvSpPr>
-        <p:spPr>
-          <a:xfrm>
-            <a:off x="1188720" y="7726679"/>
-            <a:ext cx="4693920" cy="274320"/>
-          </a:xfrm>
-          <a:prstGeom prst="rect">
-            <a:avLst/>
-          </a:prstGeom>
-          <a:noFill/>
-        </p:spPr>
-        <p:txBody>
-          <a:bodyPr wrap="square" lIns="0" rIns="0" tIns="0" bIns="0" anchor="t">
-            <a:spAutoFit/>
-          </a:bodyPr>
-          <a:lstStyle/>
-          <a:p>
-            <a:pPr algn="l"/>
-            <a:r>
-              <a:rPr sz="825" b="0" i="0" spc="80">
+          <p:cNvPr id="46" name="TextBox 45"/>
+          <p:cNvSpPr txBox="1"/>
+          <p:nvPr/>
+        </p:nvSpPr>
+        <p:spPr>
+          <a:xfrm>
+            <a:off x="1143000" y="8778240"/>
+            <a:ext cx="4785360" cy="274320"/>
+          </a:xfrm>
+          <a:prstGeom prst="rect">
+            <a:avLst/>
+          </a:prstGeom>
+          <a:noFill/>
+        </p:spPr>
+        <p:txBody>
+          <a:bodyPr wrap="square" lIns="0" rIns="0" tIns="0" bIns="0" anchor="t">
+            <a:spAutoFit/>
+          </a:bodyPr>
+          <a:lstStyle/>
+          <a:p>
+            <a:pPr algn="l"/>
+            <a:r>
+              <a:rPr sz="750" b="0" i="0" spc="80">
                 <a:solidFill>
                   <a:srgbClr val="FF8449"/>
                 </a:solidFill>
                 <a:latin typeface="Calibri"/>
               </a:rPr>
-              <a:t>BASE DE DADOS</a:t>
-            </a:r>
-          </a:p>
-        </p:txBody>
-      </p:sp>
-      <p:sp>
-        <p:nvSpPr>
-          <p:cNvPr id="37" name="TextBox 36"/>
-          <p:cNvSpPr txBox="1"/>
-          <p:nvPr/>
-        </p:nvSpPr>
-        <p:spPr>
-          <a:xfrm>
-            <a:off x="1188720" y="8001000"/>
-            <a:ext cx="4693920" cy="457200"/>
-          </a:xfrm>
-          <a:prstGeom prst="rect">
-            <a:avLst/>
-          </a:prstGeom>
-          <a:noFill/>
-        </p:spPr>
-        <p:txBody>
-          <a:bodyPr wrap="square" lIns="0" rIns="0" tIns="0" bIns="0" anchor="t">
-            <a:spAutoFit/>
-          </a:bodyPr>
-          <a:lstStyle/>
-          <a:p>
-            <a:pPr algn="l"/>
-            <a:r>
-              <a:rPr sz="1600" b="0" i="0">
+              <a:t>MEMÓRIA DA CLÍNICA</a:t>
+            </a:r>
+          </a:p>
+        </p:txBody>
+      </p:sp>
+      <p:sp>
+        <p:nvSpPr>
+          <p:cNvPr id="47" name="TextBox 46"/>
+          <p:cNvSpPr txBox="1"/>
+          <p:nvPr/>
+        </p:nvSpPr>
+        <p:spPr>
+          <a:xfrm>
+            <a:off x="1143000" y="8961119"/>
+            <a:ext cx="4785360" cy="274320"/>
+          </a:xfrm>
+          <a:prstGeom prst="rect">
+            <a:avLst/>
+          </a:prstGeom>
+          <a:noFill/>
+        </p:spPr>
+        <p:txBody>
+          <a:bodyPr wrap="square" lIns="0" rIns="0" tIns="0" bIns="0" anchor="t">
+            <a:spAutoFit/>
+          </a:bodyPr>
+          <a:lstStyle/>
+          <a:p>
+            <a:pPr algn="l"/>
+            <a:r>
+              <a:rPr sz="1200" b="0" i="0">
                 <a:solidFill>
                   <a:srgbClr val="000000"/>
                 </a:solidFill>
                 <a:latin typeface="Georgia"/>
               </a:rPr>
-              <a:t>Company Brain</a:t>
-            </a:r>
-          </a:p>
-        </p:txBody>
-      </p:sp>
-      <p:sp>
-        <p:nvSpPr>
-          <p:cNvPr id="38" name="TextBox 37"/>
-          <p:cNvSpPr txBox="1"/>
-          <p:nvPr/>
-        </p:nvSpPr>
-        <p:spPr>
-          <a:xfrm>
-            <a:off x="1188720" y="8458200"/>
-            <a:ext cx="4693920" cy="822960"/>
-          </a:xfrm>
-          <a:prstGeom prst="rect">
-            <a:avLst/>
-          </a:prstGeom>
-          <a:noFill/>
-        </p:spPr>
-        <p:txBody>
-          <a:bodyPr wrap="square" lIns="0" rIns="0" tIns="0" bIns="0" anchor="t">
-            <a:spAutoFit/>
-          </a:bodyPr>
-          <a:lstStyle/>
-          <a:p>
-            <a:pPr algn="l"/>
-            <a:r>
-              <a:rPr sz="1000" b="0" i="0">
+              <a:t>Base de dados central</a:t>
+            </a:r>
+          </a:p>
+        </p:txBody>
+      </p:sp>
+      <p:sp>
+        <p:nvSpPr>
+          <p:cNvPr id="48" name="TextBox 47"/>
+          <p:cNvSpPr txBox="1"/>
+          <p:nvPr/>
+        </p:nvSpPr>
+        <p:spPr>
+          <a:xfrm>
+            <a:off x="1143000" y="9262872"/>
+            <a:ext cx="4785360" cy="365760"/>
+          </a:xfrm>
+          <a:prstGeom prst="rect">
+            <a:avLst/>
+          </a:prstGeom>
+          <a:noFill/>
+        </p:spPr>
+        <p:txBody>
+          <a:bodyPr wrap="square" lIns="0" rIns="0" tIns="0" bIns="0" anchor="t">
+            <a:spAutoFit/>
+          </a:bodyPr>
+          <a:lstStyle/>
+          <a:p>
+            <a:pPr algn="l"/>
+            <a:r>
+              <a:rPr sz="900" b="0" i="0">
                 <a:solidFill>
                   <a:srgbClr val="4B5563"/>
                 </a:solidFill>
                 <a:latin typeface="Calibri"/>
               </a:rPr>
-              <a:t>Tudo o que a clínica produz: pacientes, visitas, mensagens, sugestões. Permanente.</a:t>
-            </a:r>
-          </a:p>
-        </p:txBody>
-      </p:sp>
-      <p:sp>
-        <p:nvSpPr>
-          <p:cNvPr id="39" name="Rounded Rectangle 38"/>
+              <a:t>Pacientes, visitas, mensagens, sugestões. Permanente. Code + Cowork escrevem aqui.</a:t>
+            </a:r>
+          </a:p>
+        </p:txBody>
+      </p:sp>
+      <p:sp>
+        <p:nvSpPr>
+          <p:cNvPr id="49" name="Rounded Rectangle 48"/>
           <p:cNvSpPr/>
           <p:nvPr/>
         </p:nvSpPr>
         <p:spPr>
           <a:xfrm>
-            <a:off x="6522720" y="7498079"/>
-            <a:ext cx="5242560" cy="1828800"/>
+            <a:off x="6522720" y="8641080"/>
+            <a:ext cx="5242560" cy="1005840"/>
           </a:xfrm>
           <a:prstGeom prst="roundRect">
             <a:avLst>
@@ -7138,29 +7528,29 @@
       </p:sp>
       <p:sp>
         <p:nvSpPr>
-          <p:cNvPr id="40" name="TextBox 39"/>
-          <p:cNvSpPr txBox="1"/>
-          <p:nvPr/>
-        </p:nvSpPr>
-        <p:spPr>
-          <a:xfrm>
-            <a:off x="6797040" y="7726679"/>
-            <a:ext cx="4693920" cy="274320"/>
-          </a:xfrm>
-          <a:prstGeom prst="rect">
-            <a:avLst/>
-          </a:prstGeom>
-          <a:noFill/>
-        </p:spPr>
-        <p:txBody>
-          <a:bodyPr wrap="square" lIns="0" rIns="0" tIns="0" bIns="0" anchor="t">
-            <a:spAutoFit/>
-          </a:bodyPr>
-          <a:lstStyle/>
-          <a:p>
-            <a:pPr algn="l"/>
-            <a:r>
-              <a:rPr sz="825" b="0" i="0" spc="80">
+          <p:cNvPr id="50" name="TextBox 49"/>
+          <p:cNvSpPr txBox="1"/>
+          <p:nvPr/>
+        </p:nvSpPr>
+        <p:spPr>
+          <a:xfrm>
+            <a:off x="6751320" y="8778240"/>
+            <a:ext cx="4785360" cy="274320"/>
+          </a:xfrm>
+          <a:prstGeom prst="rect">
+            <a:avLst/>
+          </a:prstGeom>
+          <a:noFill/>
+        </p:spPr>
+        <p:txBody>
+          <a:bodyPr wrap="square" lIns="0" rIns="0" tIns="0" bIns="0" anchor="t">
+            <a:spAutoFit/>
+          </a:bodyPr>
+          <a:lstStyle/>
+          <a:p>
+            <a:pPr algn="l"/>
+            <a:r>
+              <a:rPr sz="750" b="0" i="0" spc="80">
                 <a:solidFill>
                   <a:srgbClr val="FF8449"/>
                 </a:solidFill>
@@ -7173,29 +7563,29 @@
       </p:sp>
       <p:sp>
         <p:nvSpPr>
-          <p:cNvPr id="41" name="TextBox 40"/>
-          <p:cNvSpPr txBox="1"/>
-          <p:nvPr/>
-        </p:nvSpPr>
-        <p:spPr>
-          <a:xfrm>
-            <a:off x="6797040" y="8001000"/>
-            <a:ext cx="4693920" cy="457200"/>
-          </a:xfrm>
-          <a:prstGeom prst="rect">
-            <a:avLst/>
-          </a:prstGeom>
-          <a:noFill/>
-        </p:spPr>
-        <p:txBody>
-          <a:bodyPr wrap="square" lIns="0" rIns="0" tIns="0" bIns="0" anchor="t">
-            <a:spAutoFit/>
-          </a:bodyPr>
-          <a:lstStyle/>
-          <a:p>
-            <a:pPr algn="l"/>
-            <a:r>
-              <a:rPr sz="1600" b="0" i="0">
+          <p:cNvPr id="51" name="TextBox 50"/>
+          <p:cNvSpPr txBox="1"/>
+          <p:nvPr/>
+        </p:nvSpPr>
+        <p:spPr>
+          <a:xfrm>
+            <a:off x="6751320" y="8961119"/>
+            <a:ext cx="4785360" cy="274320"/>
+          </a:xfrm>
+          <a:prstGeom prst="rect">
+            <a:avLst/>
+          </a:prstGeom>
+          <a:noFill/>
+        </p:spPr>
+        <p:txBody>
+          <a:bodyPr wrap="square" lIns="0" rIns="0" tIns="0" bIns="0" anchor="t">
+            <a:spAutoFit/>
+          </a:bodyPr>
+          <a:lstStyle/>
+          <a:p>
+            <a:pPr algn="l"/>
+            <a:r>
+              <a:rPr sz="1200" b="0" i="0">
                 <a:solidFill>
                   <a:srgbClr val="000000"/>
                 </a:solidFill>
@@ -7208,49 +7598,49 @@
       </p:sp>
       <p:sp>
         <p:nvSpPr>
-          <p:cNvPr id="42" name="TextBox 41"/>
-          <p:cNvSpPr txBox="1"/>
-          <p:nvPr/>
-        </p:nvSpPr>
-        <p:spPr>
-          <a:xfrm>
-            <a:off x="6797040" y="8458200"/>
-            <a:ext cx="4693920" cy="822960"/>
-          </a:xfrm>
-          <a:prstGeom prst="rect">
-            <a:avLst/>
-          </a:prstGeom>
-          <a:noFill/>
-        </p:spPr>
-        <p:txBody>
-          <a:bodyPr wrap="square" lIns="0" rIns="0" tIns="0" bIns="0" anchor="t">
-            <a:spAutoFit/>
-          </a:bodyPr>
-          <a:lstStyle/>
-          <a:p>
-            <a:pPr algn="l"/>
-            <a:r>
-              <a:rPr sz="1000" b="0" i="0">
+          <p:cNvPr id="52" name="TextBox 51"/>
+          <p:cNvSpPr txBox="1"/>
+          <p:nvPr/>
+        </p:nvSpPr>
+        <p:spPr>
+          <a:xfrm>
+            <a:off x="6751320" y="9262872"/>
+            <a:ext cx="4785360" cy="365760"/>
+          </a:xfrm>
+          <a:prstGeom prst="rect">
+            <a:avLst/>
+          </a:prstGeom>
+          <a:noFill/>
+        </p:spPr>
+        <p:txBody>
+          <a:bodyPr wrap="square" lIns="0" rIns="0" tIns="0" bIns="0" anchor="t">
+            <a:spAutoFit/>
+          </a:bodyPr>
+          <a:lstStyle/>
+          <a:p>
+            <a:pPr algn="l"/>
+            <a:r>
+              <a:rPr sz="900" b="0" i="0">
                 <a:solidFill>
                   <a:srgbClr val="4B5563"/>
                 </a:solidFill>
                 <a:latin typeface="Calibri"/>
               </a:rPr>
-              <a:t>Prompts, regras, automações. Substituível conforme o Claude evolui.</a:t>
-            </a:r>
-          </a:p>
-        </p:txBody>
-      </p:sp>
-      <p:sp>
-        <p:nvSpPr>
-          <p:cNvPr id="43" name="Rounded Rectangle 42"/>
+              <a:t>Prompts, skills, regras. Source única partilhada — patches viram-se de uma vez para ambos.</a:t>
+            </a:r>
+          </a:p>
+        </p:txBody>
+      </p:sp>
+      <p:sp>
+        <p:nvSpPr>
+          <p:cNvPr id="53" name="Rounded Rectangle 52"/>
           <p:cNvSpPr/>
           <p:nvPr/>
         </p:nvSpPr>
         <p:spPr>
           <a:xfrm>
-            <a:off x="12131040" y="7498079"/>
-            <a:ext cx="5242560" cy="1828800"/>
+            <a:off x="12131040" y="8641080"/>
+            <a:ext cx="5242560" cy="1005840"/>
           </a:xfrm>
           <a:prstGeom prst="roundRect">
             <a:avLst>
@@ -7289,29 +7679,29 @@
       </p:sp>
       <p:sp>
         <p:nvSpPr>
-          <p:cNvPr id="44" name="TextBox 43"/>
-          <p:cNvSpPr txBox="1"/>
-          <p:nvPr/>
-        </p:nvSpPr>
-        <p:spPr>
-          <a:xfrm>
-            <a:off x="12405360" y="7726679"/>
-            <a:ext cx="4693920" cy="274320"/>
-          </a:xfrm>
-          <a:prstGeom prst="rect">
-            <a:avLst/>
-          </a:prstGeom>
-          <a:noFill/>
-        </p:spPr>
-        <p:txBody>
-          <a:bodyPr wrap="square" lIns="0" rIns="0" tIns="0" bIns="0" anchor="t">
-            <a:spAutoFit/>
-          </a:bodyPr>
-          <a:lstStyle/>
-          <a:p>
-            <a:pPr algn="l"/>
-            <a:r>
-              <a:rPr sz="825" b="0" i="0" spc="80">
+          <p:cNvPr id="54" name="TextBox 53"/>
+          <p:cNvSpPr txBox="1"/>
+          <p:nvPr/>
+        </p:nvSpPr>
+        <p:spPr>
+          <a:xfrm>
+            <a:off x="12359640" y="8778240"/>
+            <a:ext cx="4785360" cy="274320"/>
+          </a:xfrm>
+          <a:prstGeom prst="rect">
+            <a:avLst/>
+          </a:prstGeom>
+          <a:noFill/>
+        </p:spPr>
+        <p:txBody>
+          <a:bodyPr wrap="square" lIns="0" rIns="0" tIns="0" bIns="0" anchor="t">
+            <a:spAutoFit/>
+          </a:bodyPr>
+          <a:lstStyle/>
+          <a:p>
+            <a:pPr algn="l"/>
+            <a:r>
+              <a:rPr sz="750" b="0" i="0" spc="80">
                 <a:solidFill>
                   <a:srgbClr val="FF8449"/>
                 </a:solidFill>
@@ -7324,29 +7714,29 @@
       </p:sp>
       <p:sp>
         <p:nvSpPr>
-          <p:cNvPr id="45" name="TextBox 44"/>
-          <p:cNvSpPr txBox="1"/>
-          <p:nvPr/>
-        </p:nvSpPr>
-        <p:spPr>
-          <a:xfrm>
-            <a:off x="12405360" y="8001000"/>
-            <a:ext cx="4693920" cy="457200"/>
-          </a:xfrm>
-          <a:prstGeom prst="rect">
-            <a:avLst/>
-          </a:prstGeom>
-          <a:noFill/>
-        </p:spPr>
-        <p:txBody>
-          <a:bodyPr wrap="square" lIns="0" rIns="0" tIns="0" bIns="0" anchor="t">
-            <a:spAutoFit/>
-          </a:bodyPr>
-          <a:lstStyle/>
-          <a:p>
-            <a:pPr algn="l"/>
-            <a:r>
-              <a:rPr sz="1600" b="0" i="0">
+          <p:cNvPr id="55" name="TextBox 54"/>
+          <p:cNvSpPr txBox="1"/>
+          <p:nvPr/>
+        </p:nvSpPr>
+        <p:spPr>
+          <a:xfrm>
+            <a:off x="12359640" y="8961119"/>
+            <a:ext cx="4785360" cy="274320"/>
+          </a:xfrm>
+          <a:prstGeom prst="rect">
+            <a:avLst/>
+          </a:prstGeom>
+          <a:noFill/>
+        </p:spPr>
+        <p:txBody>
+          <a:bodyPr wrap="square" lIns="0" rIns="0" tIns="0" bIns="0" anchor="t">
+            <a:spAutoFit/>
+          </a:bodyPr>
+          <a:lstStyle/>
+          <a:p>
+            <a:pPr algn="l"/>
+            <a:r>
+              <a:rPr sz="1200" b="0" i="0">
                 <a:solidFill>
                   <a:srgbClr val="000000"/>
                 </a:solidFill>
@@ -7359,29 +7749,29 @@
       </p:sp>
       <p:sp>
         <p:nvSpPr>
-          <p:cNvPr id="46" name="TextBox 45"/>
-          <p:cNvSpPr txBox="1"/>
-          <p:nvPr/>
-        </p:nvSpPr>
-        <p:spPr>
-          <a:xfrm>
-            <a:off x="12405360" y="8458200"/>
-            <a:ext cx="4693920" cy="822960"/>
-          </a:xfrm>
-          <a:prstGeom prst="rect">
-            <a:avLst/>
-          </a:prstGeom>
-          <a:noFill/>
-        </p:spPr>
-        <p:txBody>
-          <a:bodyPr wrap="square" lIns="0" rIns="0" tIns="0" bIns="0" anchor="t">
-            <a:spAutoFit/>
-          </a:bodyPr>
-          <a:lstStyle/>
-          <a:p>
-            <a:pPr algn="l"/>
-            <a:r>
-              <a:rPr sz="1000" b="0" i="0">
+          <p:cNvPr id="56" name="TextBox 55"/>
+          <p:cNvSpPr txBox="1"/>
+          <p:nvPr/>
+        </p:nvSpPr>
+        <p:spPr>
+          <a:xfrm>
+            <a:off x="12359640" y="9262872"/>
+            <a:ext cx="4785360" cy="365760"/>
+          </a:xfrm>
+          <a:prstGeom prst="rect">
+            <a:avLst/>
+          </a:prstGeom>
+          <a:noFill/>
+        </p:spPr>
+        <p:txBody>
+          <a:bodyPr wrap="square" lIns="0" rIns="0" tIns="0" bIns="0" anchor="t">
+            <a:spAutoFit/>
+          </a:bodyPr>
+          <a:lstStyle/>
+          <a:p>
+            <a:pPr algn="l"/>
+            <a:r>
+              <a:rPr sz="900" b="0" i="0">
                 <a:solidFill>
                   <a:srgbClr val="4B5563"/>
                 </a:solidFill>
@@ -7394,7 +7784,7 @@
       </p:sp>
       <p:sp>
         <p:nvSpPr>
-          <p:cNvPr id="47" name="TextBox 46"/>
+          <p:cNvPr id="57" name="TextBox 56"/>
           <p:cNvSpPr txBox="1"/>
           <p:nvPr/>
         </p:nvSpPr>
@@ -7429,7 +7819,7 @@
       </p:sp>
       <p:sp>
         <p:nvSpPr>
-          <p:cNvPr id="48" name="TextBox 47"/>
+          <p:cNvPr id="58" name="TextBox 57"/>
           <p:cNvSpPr txBox="1"/>
           <p:nvPr/>
         </p:nvSpPr>
@@ -7464,7 +7854,7 @@
       </p:sp>
       <p:sp>
         <p:nvSpPr>
-          <p:cNvPr id="49" name="TextBox 48"/>
+          <p:cNvPr id="59" name="TextBox 58"/>
           <p:cNvSpPr txBox="1"/>
           <p:nvPr/>
         </p:nvSpPr>

</xml_diff>